<commit_message>
Remove speaker notes from Grade 5 Sage demo PPT.
Co-authored-by: Cursor <cursoragent@cursor.com>
</commit_message>
<xml_diff>
--- a/Grade5_Sage_English_Demo_90min.pptx
+++ b/Grade5_Sage_English_Demo_90min.pptx
@@ -524,36 +524,7 @@
         <p:txBody>
           <a:bodyPr/>
           <a:lstStyle/>
-          <a:p>
-            <a:r>
-              <a:t>SAY: "Hi Sage! Welcome to your English adventure. I'm so happy you're here today!"</a:t>
-            </a:r>
-          </a:p>
-          <a:p>
-            <a:r>
-              <a:t>Smile, wave, and keep energy high.</a:t>
-            </a:r>
-          </a:p>
-          <a:p>
-            <a:r>
-              <a:t>EXPECTED: Smile, greeting, maybe shy "hello."</a:t>
-            </a:r>
-          </a:p>
-          <a:p>
-            <a:r>
-              <a:t>FOLLOW-UP: "Are you ready for some fun English games?"</a:t>
-            </a:r>
-          </a:p>
-          <a:p>
-            <a:r>
-              <a:t>ASSESS: First impression of confidence and willingness to speak.</a:t>
-            </a:r>
-          </a:p>
-          <a:p>
-            <a:r>
-              <a:t>TIMING: 1–2 minutes.</a:t>
-            </a:r>
-          </a:p>
+          <a:p/>
         </p:txBody>
       </p:sp>
       <p:sp>
@@ -619,31 +590,7 @@
         <p:txBody>
           <a:bodyPr/>
           <a:lstStyle/>
-          <a:p>
-            <a:r>
-              <a:t>Click through one question at a time verbally. Celebrate streaks.</a:t>
-            </a:r>
-          </a:p>
-          <a:p>
-            <a:r>
-              <a:t>ANSWERS: 1B 2C 3B 4A 5B 6A 7B 8A 9B 10A (also on Slide 23).</a:t>
-            </a:r>
-          </a:p>
-          <a:p>
-            <a:r>
-              <a:t>If wrong, teach the "why" in 10 seconds, then move on.</a:t>
-            </a:r>
-          </a:p>
-          <a:p>
-            <a:r>
-              <a:t>ASSESS: Speed + accuracy under light pressure.</a:t>
-            </a:r>
-          </a:p>
-          <a:p>
-            <a:r>
-              <a:t>TIMING: ~7 minutes.</a:t>
-            </a:r>
-          </a:p>
+          <a:p/>
         </p:txBody>
       </p:sp>
       <p:sp>
@@ -709,36 +656,7 @@
         <p:txBody>
           <a:bodyPr/>
           <a:lstStyle/>
-          <a:p>
-            <a:r>
-              <a:t>Teach 8–12 words based on time. Say → student repeats → meaning → example.</a:t>
-            </a:r>
-          </a:p>
-          <a:p>
-            <a:r>
-              <a:t>Act out soar, breeze, drizzle for memory.</a:t>
-            </a:r>
-          </a:p>
-          <a:p>
-            <a:r>
-              <a:t>EXPECTED: Correct repetition; attempt own sentence for 2–3 words.</a:t>
-            </a:r>
-          </a:p>
-          <a:p>
-            <a:r>
-              <a:t>FOLLOW-UP: "Which word fits: soft wind?"</a:t>
-            </a:r>
-          </a:p>
-          <a:p>
-            <a:r>
-              <a:t>ASSESS: Pronunciation + meaning retention.</a:t>
-            </a:r>
-          </a:p>
-          <a:p>
-            <a:r>
-              <a:t>TIMING: ~7 minutes.</a:t>
-            </a:r>
-          </a:p>
+          <a:p/>
         </p:txBody>
       </p:sp>
       <p:sp>
@@ -804,31 +722,7 @@
         <p:txBody>
           <a:bodyPr/>
           <a:lstStyle/>
-          <a:p>
-            <a:r>
-              <a:t>Sage draws imaginary lines or says "1 goes with B."</a:t>
-            </a:r>
-          </a:p>
-          <a:p>
-            <a:r>
-              <a:t>KEY: 1-B, 2-D, 3-A, 4-E, 5-F, 6-C.</a:t>
-            </a:r>
-          </a:p>
-          <a:p>
-            <a:r>
-              <a:t>Keep score for fun (not pressure).</a:t>
-            </a:r>
-          </a:p>
-          <a:p>
-            <a:r>
-              <a:t>ASSESS: Word-meaning mapping speed.</a:t>
-            </a:r>
-          </a:p>
-          <a:p>
-            <a:r>
-              <a:t>TIMING: ~4 minutes.</a:t>
-            </a:r>
-          </a:p>
+          <a:p/>
         </p:txBody>
       </p:sp>
       <p:sp>
@@ -894,31 +788,7 @@
         <p:txBody>
           <a:bodyPr/>
           <a:lstStyle/>
-          <a:p>
-            <a:r>
-              <a:t>Explain synonym = similar, antonym = opposite with hand gestures.</a:t>
-            </a:r>
-          </a:p>
-          <a:p>
-            <a:r>
-              <a:t>EXPECTED: big→large/huge; kind→mean/unkind/cruel.</a:t>
-            </a:r>
-          </a:p>
-          <a:p>
-            <a:r>
-              <a:t>Connect to passage: tiny/sad/proud.</a:t>
-            </a:r>
-          </a:p>
-          <a:p>
-            <a:r>
-              <a:t>ASSESS: Lexical flexibility.</a:t>
-            </a:r>
-          </a:p>
-          <a:p>
-            <a:r>
-              <a:t>TIMING: ~4 minutes (end vocab block).</a:t>
-            </a:r>
-          </a:p>
+          <a:p/>
         </p:txBody>
       </p:sp>
       <p:sp>
@@ -984,36 +854,7 @@
         <p:txBody>
           <a:bodyPr/>
           <a:lstStyle/>
-          <a:p>
-            <a:r>
-              <a:t>SAY: "Use the picture. Invent a NEW story (not only The Lost Puppy)."</a:t>
-            </a:r>
-          </a:p>
-          <a:p>
-            <a:r>
-              <a:t>Give 30 seconds planning. Aim for 6–10 sentences.</a:t>
-            </a:r>
-          </a:p>
-          <a:p>
-            <a:r>
-              <a:t>EXPECTED: Clear who/where/problem/solution; creative details.</a:t>
-            </a:r>
-          </a:p>
-          <a:p>
-            <a:r>
-              <a:t>FOLLOW-UP: "Add one nature vocabulary word from today!"</a:t>
-            </a:r>
-          </a:p>
-          <a:p>
-            <a:r>
-              <a:t>ASSESS: Creativity, coherence, grammar in extended speech.</a:t>
-            </a:r>
-          </a:p>
-          <a:p>
-            <a:r>
-              <a:t>TIMING: ~5 minutes of storytelling block.</a:t>
-            </a:r>
-          </a:p>
+          <a:p/>
         </p:txBody>
       </p:sp>
       <p:sp>
@@ -1079,26 +920,7 @@
         <p:txBody>
           <a:bodyPr/>
           <a:lstStyle/>
-          <a:p>
-            <a:r>
-              <a:t>Student describes for 60–90 seconds using all four boxes.</a:t>
-            </a:r>
-          </a:p>
-          <a:p>
-            <a:r>
-              <a:t>Push adjectives: colorful, excited, noisy, delicious.</a:t>
-            </a:r>
-          </a:p>
-          <a:p>
-            <a:r>
-              <a:t>ASSESS: Observation language, present continuous (are laughing).</a:t>
-            </a:r>
-          </a:p>
-          <a:p>
-            <a:r>
-              <a:t>TIMING: ~3 minutes.</a:t>
-            </a:r>
-          </a:p>
+          <a:p/>
         </p:txBody>
       </p:sp>
       <p:sp>
@@ -1164,31 +986,7 @@
         <p:txBody>
           <a:bodyPr/>
           <a:lstStyle/>
-          <a:p>
-            <a:r>
-              <a:t>Let Sage choose one role. Teacher can be the audience/interviewer.</a:t>
-            </a:r>
-          </a:p>
-          <a:p>
-            <a:r>
-              <a:t>EXPECTED: Imaginative language; attempt formal tone for reporter.</a:t>
-            </a:r>
-          </a:p>
-          <a:p>
-            <a:r>
-              <a:t>FOLLOW-UP: "What happens next in your news story?"</a:t>
-            </a:r>
-          </a:p>
-          <a:p>
-            <a:r>
-              <a:t>ASSESS: Confidence, creativity, pronunciation under performance.</a:t>
-            </a:r>
-          </a:p>
-          <a:p>
-            <a:r>
-              <a:t>TIMING: ~2 minutes (flex if early).</a:t>
-            </a:r>
-          </a:p>
+          <a:p/>
         </p:txBody>
       </p:sp>
       <p:sp>
@@ -1254,31 +1052,7 @@
         <p:txBody>
           <a:bodyPr/>
           <a:lstStyle/>
-          <a:p>
-            <a:r>
-              <a:t>Model clearly; clap syllables. Do 6–10 words based on time.</a:t>
-            </a:r>
-          </a:p>
-          <a:p>
-            <a:r>
-              <a:t>Common errors: library (not lie-berry), Wednesday (silent d).</a:t>
-            </a:r>
-          </a:p>
-          <a:p>
-            <a:r>
-              <a:t>EXPECTED: Improved approximation after 2 repeats.</a:t>
-            </a:r>
-          </a:p>
-          <a:p>
-            <a:r>
-              <a:t>ASSESS: Segmentals + confidence saying hard words aloud.</a:t>
-            </a:r>
-          </a:p>
-          <a:p>
-            <a:r>
-              <a:t>TIMING: 3 minutes (squeeze into speaking/story block if needed).</a:t>
-            </a:r>
-          </a:p>
+          <a:p/>
         </p:txBody>
       </p:sp>
       <p:sp>
@@ -1344,26 +1118,7 @@
         <p:txBody>
           <a:bodyPr/>
           <a:lstStyle/>
-          <a:p>
-            <a:r>
-              <a:t>Rapid-fire quiz. Keep celebratory tone.</a:t>
-            </a:r>
-          </a:p>
-          <a:p>
-            <a:r>
-              <a:t>ANSWERS: B, B, C, B, A, A, B, B.</a:t>
-            </a:r>
-          </a:p>
-          <a:p>
-            <a:r>
-              <a:t>ASSESS: Retention across skills.</a:t>
-            </a:r>
-          </a:p>
-          <a:p>
-            <a:r>
-              <a:t>TIMING: ~4 minutes before assessment/recap.</a:t>
-            </a:r>
-          </a:p>
+          <a:p/>
         </p:txBody>
       </p:sp>
       <p:sp>
@@ -1429,26 +1184,7 @@
         <p:txBody>
           <a:bodyPr/>
           <a:lstStyle/>
-          <a:p>
-            <a:r>
-              <a:t>Complete privately during/after class (do not stress Sage).</a:t>
-            </a:r>
-          </a:p>
-          <a:p>
-            <a:r>
-              <a:t>1=emerging … 5=excellent for Grade 5 demo expectations.</a:t>
-            </a:r>
-          </a:p>
-          <a:p>
-            <a:r>
-              <a:t>Note 1 strength + 1 growth area for parents.</a:t>
-            </a:r>
-          </a:p>
-          <a:p>
-            <a:r>
-              <a:t>TIMING: Ongoing observation; finalize in last 2 minutes.</a:t>
-            </a:r>
-          </a:p>
+          <a:p/>
         </p:txBody>
       </p:sp>
       <p:sp>
@@ -1514,41 +1250,7 @@
         <p:txBody>
           <a:bodyPr/>
           <a:lstStyle/>
-          <a:p>
-            <a:r>
-              <a:t>SAY: Introduce yourself warmly. Share name, fun fact, favorite book.</a:t>
-            </a:r>
-          </a:p>
-          <a:p>
-            <a:r>
-              <a:t>Then point to Sage's card: "Now tell me about you!"</a:t>
-            </a:r>
-          </a:p>
-          <a:p>
-            <a:r>
-              <a:t>ASK one question at a time. Wait patiently.</a:t>
-            </a:r>
-          </a:p>
-          <a:p>
-            <a:r>
-              <a:t>EXPECTED: Short answers; encourage full sentences: "I study at…"</a:t>
-            </a:r>
-          </a:p>
-          <a:p>
-            <a:r>
-              <a:t>FOLLOW-UP: "That's awesome! Tell me one more thing about your hobby."</a:t>
-            </a:r>
-          </a:p>
-          <a:p>
-            <a:r>
-              <a:t>ASSESS: Pronunciation, fluency, confidence, listening.</a:t>
-            </a:r>
-          </a:p>
-          <a:p>
-            <a:r>
-              <a:t>TIMING: 5 minutes.</a:t>
-            </a:r>
-          </a:p>
+          <a:p/>
         </p:txBody>
       </p:sp>
       <p:sp>
@@ -1614,26 +1316,7 @@
         <p:txBody>
           <a:bodyPr/>
           <a:lstStyle/>
-          <a:p>
-            <a:r>
-              <a:t>Quick student-led recap. Ask favorite activity.</a:t>
-            </a:r>
-          </a:p>
-          <a:p>
-            <a:r>
-              <a:t>EXPECTED: Mentions a game/story/word.</a:t>
-            </a:r>
-          </a:p>
-          <a:p>
-            <a:r>
-              <a:t>End with specific praise: "Your evidence answers were excellent!"</a:t>
-            </a:r>
-          </a:p>
-          <a:p>
-            <a:r>
-              <a:t>TIMING: 5 minutes.</a:t>
-            </a:r>
-          </a:p>
+          <a:p/>
         </p:txBody>
       </p:sp>
       <p:sp>
@@ -1699,21 +1382,7 @@
         <p:txBody>
           <a:bodyPr/>
           <a:lstStyle/>
-          <a:p>
-            <a:r>
-              <a:t>Explain homework clearly; keep it light and doable (15–20 min).</a:t>
-            </a:r>
-          </a:p>
-          <a:p>
-            <a:r>
-              <a:t>Optional share next class.</a:t>
-            </a:r>
-          </a:p>
-          <a:p>
-            <a:r>
-              <a:t>TIMING: 1–2 minutes.</a:t>
-            </a:r>
-          </a:p>
+          <a:p/>
         </p:txBody>
       </p:sp>
       <p:sp>
@@ -1779,26 +1448,7 @@
         <p:txBody>
           <a:bodyPr/>
           <a:lstStyle/>
-          <a:p>
-            <a:r>
-              <a:t>Celebrate specifically: name 2 strengths observed.</a:t>
-            </a:r>
-          </a:p>
-          <a:p>
-            <a:r>
-              <a:t>Thank Sage and parents if present.</a:t>
-            </a:r>
-          </a:p>
-          <a:p>
-            <a:r>
-              <a:t>Invite questions.</a:t>
-            </a:r>
-          </a:p>
-          <a:p>
-            <a:r>
-              <a:t>TIMING: 1–2 minutes closing.</a:t>
-            </a:r>
-          </a:p>
+          <a:p/>
         </p:txBody>
       </p:sp>
       <p:sp>
@@ -1864,16 +1514,7 @@
         <p:txBody>
           <a:bodyPr/>
           <a:lstStyle/>
-          <a:p>
-            <a:r>
-              <a:t>Teacher reference only — reveal after student attempts.</a:t>
-            </a:r>
-          </a:p>
-          <a:p>
-            <a:r>
-              <a:t>Use to confirm scoring and parent feedback examples.</a:t>
-            </a:r>
-          </a:p>
+          <a:p/>
         </p:txBody>
       </p:sp>
       <p:sp>
@@ -1939,11 +1580,7 @@
         <p:txBody>
           <a:bodyPr/>
           <a:lstStyle/>
-          <a:p>
-            <a:r>
-              <a:t>Teacher key. Reveal answers with celebration animations verbally ("Ding!").</a:t>
-            </a:r>
-          </a:p>
+          <a:p/>
         </p:txBody>
       </p:sp>
       <p:sp>
@@ -2009,21 +1646,7 @@
         <p:txBody>
           <a:bodyPr/>
           <a:lstStyle/>
-          <a:p>
-            <a:r>
-              <a:t>Use this map to stay on pace. If Sage needs more speaking time, shorten quiz.</a:t>
-            </a:r>
-          </a:p>
-          <a:p>
-            <a:r>
-              <a:t>Pronunciation slide is flexible—insert when energy dips.</a:t>
-            </a:r>
-          </a:p>
-          <a:p>
-            <a:r>
-              <a:t>Parent wow factor: specific praise + clear next step (homework).</a:t>
-            </a:r>
-          </a:p>
+          <a:p/>
         </p:txBody>
       </p:sp>
       <p:sp>
@@ -2089,41 +1712,7 @@
         <p:txBody>
           <a:bodyPr/>
           <a:lstStyle/>
-          <a:p>
-            <a:r>
-              <a:t>SAY: "This is Would You Rather! Pick one option and tell me WHY in a full sentence."</a:t>
-            </a:r>
-          </a:p>
-          <a:p>
-            <a:r>
-              <a:t>Model first: "I would rather ride a unicorn because it looks magical!"</a:t>
-            </a:r>
-          </a:p>
-          <a:p>
-            <a:r>
-              <a:t>Do 5–8 questions depending on energy. Keep it playful.</a:t>
-            </a:r>
-          </a:p>
-          <a:p>
-            <a:r>
-              <a:t>EXPECTED: Full sentences with because.</a:t>
-            </a:r>
-          </a:p>
-          <a:p>
-            <a:r>
-              <a:t>FOLLOW-UP: "Interesting! Can you add one more reason?"</a:t>
-            </a:r>
-          </a:p>
-          <a:p>
-            <a:r>
-              <a:t>ASSESS: Speaking fluency, vocabulary, confidence, sentence structure.</a:t>
-            </a:r>
-          </a:p>
-          <a:p>
-            <a:r>
-              <a:t>TIMING: 10 minutes.</a:t>
-            </a:r>
-          </a:p>
+          <a:p/>
         </p:txBody>
       </p:sp>
       <p:sp>
@@ -2189,36 +1778,7 @@
         <p:txBody>
           <a:bodyPr/>
           <a:lstStyle/>
-          <a:p>
-            <a:r>
-              <a:t>SAY each prompt slowly. Give Sage 20–30 seconds think time.</a:t>
-            </a:r>
-          </a:p>
-          <a:p>
-            <a:r>
-              <a:t>Encourage 3–5 sentences, not one-word answers.</a:t>
-            </a:r>
-          </a:p>
-          <a:p>
-            <a:r>
-              <a:t>EXPECTED: Past tense on weekend; imaginative language on superpower.</a:t>
-            </a:r>
-          </a:p>
-          <a:p>
-            <a:r>
-              <a:t>FOLLOW-UP: "What happened next?" "How did that make you feel?"</a:t>
-            </a:r>
-          </a:p>
-          <a:p>
-            <a:r>
-              <a:t>ASSESS: Fluency, pronunciation, vocabulary range, confidence.</a:t>
-            </a:r>
-          </a:p>
-          <a:p>
-            <a:r>
-              <a:t>TIMING: 5 minutes (part of intro block).</a:t>
-            </a:r>
-          </a:p>
+          <a:p/>
         </p:txBody>
       </p:sp>
       <p:sp>
@@ -2284,41 +1844,7 @@
         <p:txBody>
           <a:bodyPr/>
           <a:lstStyle/>
-          <a:p>
-            <a:r>
-              <a:t>SAY: "Today's story is The Lost Puppy. First I'll read; then you can read parts."</a:t>
-            </a:r>
-          </a:p>
-          <a:p>
-            <a:r>
-              <a:t>Teacher reads with expression. Then Sage reads 1–2 paragraphs.</a:t>
-            </a:r>
-          </a:p>
-          <a:p>
-            <a:r>
-              <a:t>Help with tricky words gently (cheerfully, whimper, dialed).</a:t>
-            </a:r>
-          </a:p>
-          <a:p>
-            <a:r>
-              <a:t>EXPECTED: Follow along; ask about unknown words.</a:t>
-            </a:r>
-          </a:p>
-          <a:p>
-            <a:r>
-              <a:t>FOLLOW-UP: "Which part did you like most?"</a:t>
-            </a:r>
-          </a:p>
-          <a:p>
-            <a:r>
-              <a:t>ASSESS: Decoding, fluency, expression, comprehension while listening.</a:t>
-            </a:r>
-          </a:p>
-          <a:p>
-            <a:r>
-              <a:t>TIMING: ~8–10 minutes of the 20-min reading block.</a:t>
-            </a:r>
-          </a:p>
+          <a:p/>
         </p:txBody>
       </p:sp>
       <p:sp>
@@ -2384,36 +1910,7 @@
         <p:txBody>
           <a:bodyPr/>
           <a:lstStyle/>
-          <a:p>
-            <a:r>
-              <a:t>Ask questions one by one. Celebrate evidence: "Where in the story did you find that?"</a:t>
-            </a:r>
-          </a:p>
-          <a:p>
-            <a:r>
-              <a:t>EXPECTED ANSWERS (preview): B; C; False; True; water; poster; kindness/helping; B.</a:t>
-            </a:r>
-          </a:p>
-          <a:p>
-            <a:r>
-              <a:t>FOLLOW-UP for #7: "What clue in the text shows her pride?"</a:t>
-            </a:r>
-          </a:p>
-          <a:p>
-            <a:r>
-              <a:t>ASSESS: Literal vs inferential understanding; vocabulary in context.</a:t>
-            </a:r>
-          </a:p>
-          <a:p>
-            <a:r>
-              <a:t>Full answer key on Slide 23.</a:t>
-            </a:r>
-          </a:p>
-          <a:p>
-            <a:r>
-              <a:t>TIMING: ~8 minutes.</a:t>
-            </a:r>
-          </a:p>
+          <a:p/>
         </p:txBody>
       </p:sp>
       <p:sp>
@@ -2479,36 +1976,7 @@
         <p:txBody>
           <a:bodyPr/>
           <a:lstStyle/>
-          <a:p>
-            <a:r>
-              <a:t>SAY: "Pretend I'm a friend who hasn't heard the story. Retell it using these four steps."</a:t>
-            </a:r>
-          </a:p>
-          <a:p>
-            <a:r>
-              <a:t>Allow notes if needed; discourage reading the passage word-for-word.</a:t>
-            </a:r>
-          </a:p>
-          <a:p>
-            <a:r>
-              <a:t>EXPECTED: Clear sequence; past tense; key details (Coco, poster, Ava).</a:t>
-            </a:r>
-          </a:p>
-          <a:p>
-            <a:r>
-              <a:t>FOLLOW-UP: "Can you add how Mia felt when she first saw the puppy?"</a:t>
-            </a:r>
-          </a:p>
-          <a:p>
-            <a:r>
-              <a:t>ASSESS: Oral organization, vocabulary, grammar in speech, confidence.</a:t>
-            </a:r>
-          </a:p>
-          <a:p>
-            <a:r>
-              <a:t>TIMING: ~5 minutes (end of reading block).</a:t>
-            </a:r>
-          </a:p>
+          <a:p/>
         </p:txBody>
       </p:sp>
       <p:sp>
@@ -2574,36 +2042,7 @@
         <p:txBody>
           <a:bodyPr/>
           <a:lstStyle/>
-          <a:p>
-            <a:r>
-              <a:t>Teach each part with finger gestures (point for noun, act for verb, paint for adjective, speed for adverb).</a:t>
-            </a:r>
-          </a:p>
-          <a:p>
-            <a:r>
-              <a:t>Use story examples so grammar connects to reading.</a:t>
-            </a:r>
-          </a:p>
-          <a:p>
-            <a:r>
-              <a:t>EXPECTED: Sage can give one new example for each.</a:t>
-            </a:r>
-          </a:p>
-          <a:p>
-            <a:r>
-              <a:t>FOLLOW-UP: "Is 'quickly' an adjective or adverb? Why?"</a:t>
-            </a:r>
-          </a:p>
-          <a:p>
-            <a:r>
-              <a:t>ASSESS: Concept understanding before practice.</a:t>
-            </a:r>
-          </a:p>
-          <a:p>
-            <a:r>
-              <a:t>TIMING: ~6 minutes.</a:t>
-            </a:r>
-          </a:p>
+          <a:p/>
         </p:txBody>
       </p:sp>
       <p:sp>
@@ -2669,36 +2108,7 @@
         <p:txBody>
           <a:bodyPr/>
           <a:lstStyle/>
-          <a:p>
-            <a:r>
-              <a:t>Treat like live drag-and-drop: Sage says or points to the word.</a:t>
-            </a:r>
-          </a:p>
-          <a:p>
-            <a:r>
-              <a:t>ANSWERS: walked; tiny/brown; birds; gently; Happy(adj) Ava(n) quickly(adv) hugged(v) Coco(n).</a:t>
-            </a:r>
-          </a:p>
-          <a:p>
-            <a:r>
-              <a:t>For task 6, praise creativity.</a:t>
-            </a:r>
-          </a:p>
-          <a:p>
-            <a:r>
-              <a:t>FOLLOW-UP: "Can you change the adjective to make a new meaning?"</a:t>
-            </a:r>
-          </a:p>
-          <a:p>
-            <a:r>
-              <a:t>ASSESS: Accuracy + reasoning.</a:t>
-            </a:r>
-          </a:p>
-          <a:p>
-            <a:r>
-              <a:t>TIMING: ~7 minutes.</a:t>
-            </a:r>
-          </a:p>
+          <a:p/>
         </p:txBody>
       </p:sp>
       <p:sp>

</xml_diff>